<commit_message>
plotted timestamp on x axis in sec
legend displays correct total elapsed time
</commit_message>
<xml_diff>
--- a/kinematic presentations/Zeyad Abduction Analysis 2_18_26.pptx
+++ b/kinematic presentations/Zeyad Abduction Analysis 2_18_26.pptx
@@ -13,6 +13,8 @@
     <p:sldId id="261" r:id="rId7"/>
     <p:sldId id="262" r:id="rId8"/>
     <p:sldId id="263" r:id="rId9"/>
+    <p:sldId id="264" r:id="rId10"/>
+    <p:sldId id="265" r:id="rId11"/>
   </p:sldIdLst>
   <p:sldSz cx="12192000" cy="6858000"/>
   <p:notesSz cx="6858000" cy="9144000"/>
@@ -111,7 +113,20 @@
       </a:defRPr>
     </a:lvl9pPr>
   </p:defaultTextStyle>
+  <p:extLst>
+    <p:ext uri="{EFAFB233-063F-42B5-8137-9DF3F51BA10A}">
+      <p15:sldGuideLst xmlns:p15="http://schemas.microsoft.com/office/powerpoint/2012/main"/>
+    </p:ext>
+  </p:extLst>
 </p:presentation>
+</file>
+
+<file path=ppt/revisionInfo.xml><?xml version="1.0" encoding="utf-8"?>
+<p1510:revInfo xmlns:a="http://schemas.openxmlformats.org/drawingml/2006/main" xmlns:r="http://schemas.openxmlformats.org/officeDocument/2006/relationships" xmlns:p1510="http://schemas.microsoft.com/office/powerpoint/2015/10/main">
+  <p1510:revLst>
+    <p1510:client id="{EF4E1A01-6777-412E-8E47-6F7C8A397BFC}" v="4" dt="2026-03-05T20:21:05.813"/>
+  </p1510:revLst>
+</p1510:revInfo>
 </file>
 
 <file path=ppt/changesInfos/changesInfo1.xml><?xml version="1.0" encoding="utf-8"?>
@@ -119,7 +134,7 @@
   <pc:docChgLst>
     <pc:chgData name="Oppenheim, Tomas" userId="7bbdd6b4-1f3d-4fdd-ac21-d8c716941374" providerId="ADAL" clId="{868CCE3B-0BC1-45F9-B792-6C1CD11EB596}"/>
     <pc:docChg chg="custSel addSld modSld">
-      <pc:chgData name="Oppenheim, Tomas" userId="7bbdd6b4-1f3d-4fdd-ac21-d8c716941374" providerId="ADAL" clId="{868CCE3B-0BC1-45F9-B792-6C1CD11EB596}" dt="2026-02-18T16:29:41.320" v="1471" actId="20577"/>
+      <pc:chgData name="Oppenheim, Tomas" userId="7bbdd6b4-1f3d-4fdd-ac21-d8c716941374" providerId="ADAL" clId="{868CCE3B-0BC1-45F9-B792-6C1CD11EB596}" dt="2026-03-05T20:24:09.912" v="2283" actId="14100"/>
       <pc:docMkLst>
         <pc:docMk/>
       </pc:docMkLst>
@@ -160,14 +175,6 @@
             <ac:spMk id="2" creationId="{26D98D22-CBFA-783E-AC36-1E6DCDDE5260}"/>
           </ac:spMkLst>
         </pc:spChg>
-        <pc:spChg chg="del">
-          <ac:chgData name="Oppenheim, Tomas" userId="7bbdd6b4-1f3d-4fdd-ac21-d8c716941374" providerId="ADAL" clId="{868CCE3B-0BC1-45F9-B792-6C1CD11EB596}" dt="2026-02-18T16:12:18.088" v="41" actId="478"/>
-          <ac:spMkLst>
-            <pc:docMk/>
-            <pc:sldMk cId="4196373178" sldId="259"/>
-            <ac:spMk id="3" creationId="{9C963091-7066-EE4E-0286-819DB8EEBBC6}"/>
-          </ac:spMkLst>
-        </pc:spChg>
         <pc:picChg chg="add mod">
           <ac:chgData name="Oppenheim, Tomas" userId="7bbdd6b4-1f3d-4fdd-ac21-d8c716941374" providerId="ADAL" clId="{868CCE3B-0BC1-45F9-B792-6C1CD11EB596}" dt="2026-02-18T16:12:27.228" v="46" actId="1076"/>
           <ac:picMkLst>
@@ -191,14 +198,6 @@
             <ac:spMk id="2" creationId="{2FFF3B64-01C1-9493-1E00-5283D13BF7B4}"/>
           </ac:spMkLst>
         </pc:spChg>
-        <pc:spChg chg="del">
-          <ac:chgData name="Oppenheim, Tomas" userId="7bbdd6b4-1f3d-4fdd-ac21-d8c716941374" providerId="ADAL" clId="{868CCE3B-0BC1-45F9-B792-6C1CD11EB596}" dt="2026-02-18T16:13:05.853" v="103" actId="478"/>
-          <ac:spMkLst>
-            <pc:docMk/>
-            <pc:sldMk cId="517137620" sldId="260"/>
-            <ac:spMk id="3" creationId="{3913FD4D-C0F2-BA2F-8864-8259FB74B321}"/>
-          </ac:spMkLst>
-        </pc:spChg>
         <pc:picChg chg="add mod">
           <ac:chgData name="Oppenheim, Tomas" userId="7bbdd6b4-1f3d-4fdd-ac21-d8c716941374" providerId="ADAL" clId="{868CCE3B-0BC1-45F9-B792-6C1CD11EB596}" dt="2026-02-18T16:15:22.043" v="107" actId="1076"/>
           <ac:picMkLst>
@@ -220,14 +219,6 @@
             <pc:docMk/>
             <pc:sldMk cId="1748184834" sldId="261"/>
             <ac:spMk id="2" creationId="{2F37B07E-47CB-3726-AEFA-D7D3D4CF5A57}"/>
-          </ac:spMkLst>
-        </pc:spChg>
-        <pc:spChg chg="del">
-          <ac:chgData name="Oppenheim, Tomas" userId="7bbdd6b4-1f3d-4fdd-ac21-d8c716941374" providerId="ADAL" clId="{868CCE3B-0BC1-45F9-B792-6C1CD11EB596}" dt="2026-02-18T16:18:20.698" v="199" actId="478"/>
-          <ac:spMkLst>
-            <pc:docMk/>
-            <pc:sldMk cId="1748184834" sldId="261"/>
-            <ac:spMk id="3" creationId="{128DC449-AD1C-6C57-6931-41E3796CCCBC}"/>
           </ac:spMkLst>
         </pc:spChg>
         <pc:picChg chg="add mod">
@@ -285,6 +276,84 @@
           </ac:spMkLst>
         </pc:spChg>
       </pc:sldChg>
+      <pc:sldChg chg="modSp add mod">
+        <pc:chgData name="Oppenheim, Tomas" userId="7bbdd6b4-1f3d-4fdd-ac21-d8c716941374" providerId="ADAL" clId="{868CCE3B-0BC1-45F9-B792-6C1CD11EB596}" dt="2026-03-05T20:17:31.103" v="1481" actId="20577"/>
+        <pc:sldMkLst>
+          <pc:docMk/>
+          <pc:sldMk cId="640338337" sldId="264"/>
+        </pc:sldMkLst>
+        <pc:spChg chg="mod">
+          <ac:chgData name="Oppenheim, Tomas" userId="7bbdd6b4-1f3d-4fdd-ac21-d8c716941374" providerId="ADAL" clId="{868CCE3B-0BC1-45F9-B792-6C1CD11EB596}" dt="2026-03-05T20:17:31.103" v="1481" actId="20577"/>
+          <ac:spMkLst>
+            <pc:docMk/>
+            <pc:sldMk cId="640338337" sldId="264"/>
+            <ac:spMk id="3" creationId="{27390C7A-468F-1B77-5F21-0E433834E152}"/>
+          </ac:spMkLst>
+        </pc:spChg>
+      </pc:sldChg>
+      <pc:sldChg chg="addSp delSp modSp new mod">
+        <pc:chgData name="Oppenheim, Tomas" userId="7bbdd6b4-1f3d-4fdd-ac21-d8c716941374" providerId="ADAL" clId="{868CCE3B-0BC1-45F9-B792-6C1CD11EB596}" dt="2026-03-05T20:24:09.912" v="2283" actId="14100"/>
+        <pc:sldMkLst>
+          <pc:docMk/>
+          <pc:sldMk cId="2413865537" sldId="265"/>
+        </pc:sldMkLst>
+        <pc:spChg chg="del">
+          <ac:chgData name="Oppenheim, Tomas" userId="7bbdd6b4-1f3d-4fdd-ac21-d8c716941374" providerId="ADAL" clId="{868CCE3B-0BC1-45F9-B792-6C1CD11EB596}" dt="2026-03-05T20:18:16.151" v="1483" actId="478"/>
+          <ac:spMkLst>
+            <pc:docMk/>
+            <pc:sldMk cId="2413865537" sldId="265"/>
+            <ac:spMk id="2" creationId="{A1823BAC-BE65-C403-54F8-B82A4BB380E6}"/>
+          </ac:spMkLst>
+        </pc:spChg>
+        <pc:spChg chg="del">
+          <ac:chgData name="Oppenheim, Tomas" userId="7bbdd6b4-1f3d-4fdd-ac21-d8c716941374" providerId="ADAL" clId="{868CCE3B-0BC1-45F9-B792-6C1CD11EB596}" dt="2026-03-05T20:18:18.396" v="1484" actId="478"/>
+          <ac:spMkLst>
+            <pc:docMk/>
+            <pc:sldMk cId="2413865537" sldId="265"/>
+            <ac:spMk id="3" creationId="{661593AE-CCC3-A010-5F9F-59592B5F2702}"/>
+          </ac:spMkLst>
+        </pc:spChg>
+        <pc:spChg chg="add mod">
+          <ac:chgData name="Oppenheim, Tomas" userId="7bbdd6b4-1f3d-4fdd-ac21-d8c716941374" providerId="ADAL" clId="{868CCE3B-0BC1-45F9-B792-6C1CD11EB596}" dt="2026-03-05T20:19:59.098" v="1700" actId="1076"/>
+          <ac:spMkLst>
+            <pc:docMk/>
+            <pc:sldMk cId="2413865537" sldId="265"/>
+            <ac:spMk id="9" creationId="{C500F999-4E38-9E43-24B6-29A32C72BDB8}"/>
+          </ac:spMkLst>
+        </pc:spChg>
+        <pc:spChg chg="add mod">
+          <ac:chgData name="Oppenheim, Tomas" userId="7bbdd6b4-1f3d-4fdd-ac21-d8c716941374" providerId="ADAL" clId="{868CCE3B-0BC1-45F9-B792-6C1CD11EB596}" dt="2026-03-05T20:21:01.955" v="1921" actId="20577"/>
+          <ac:spMkLst>
+            <pc:docMk/>
+            <pc:sldMk cId="2413865537" sldId="265"/>
+            <ac:spMk id="10" creationId="{26A3D7C1-686F-6F31-A87D-D6BDCAD0B298}"/>
+          </ac:spMkLst>
+        </pc:spChg>
+        <pc:spChg chg="add mod">
+          <ac:chgData name="Oppenheim, Tomas" userId="7bbdd6b4-1f3d-4fdd-ac21-d8c716941374" providerId="ADAL" clId="{868CCE3B-0BC1-45F9-B792-6C1CD11EB596}" dt="2026-03-05T20:24:09.912" v="2283" actId="14100"/>
+          <ac:spMkLst>
+            <pc:docMk/>
+            <pc:sldMk cId="2413865537" sldId="265"/>
+            <ac:spMk id="11" creationId="{03EB4E9E-0E9F-C4ED-5409-7AA4AF1A72BB}"/>
+          </ac:spMkLst>
+        </pc:spChg>
+        <pc:picChg chg="add">
+          <ac:chgData name="Oppenheim, Tomas" userId="7bbdd6b4-1f3d-4fdd-ac21-d8c716941374" providerId="ADAL" clId="{868CCE3B-0BC1-45F9-B792-6C1CD11EB596}" dt="2026-03-05T20:18:19.219" v="1485" actId="22"/>
+          <ac:picMkLst>
+            <pc:docMk/>
+            <pc:sldMk cId="2413865537" sldId="265"/>
+            <ac:picMk id="5" creationId="{776023DB-349E-84E2-C86F-03F8110B33A4}"/>
+          </ac:picMkLst>
+        </pc:picChg>
+        <pc:cxnChg chg="add mod">
+          <ac:chgData name="Oppenheim, Tomas" userId="7bbdd6b4-1f3d-4fdd-ac21-d8c716941374" providerId="ADAL" clId="{868CCE3B-0BC1-45F9-B792-6C1CD11EB596}" dt="2026-03-05T20:18:40.251" v="1489" actId="13822"/>
+          <ac:cxnSpMkLst>
+            <pc:docMk/>
+            <pc:sldMk cId="2413865537" sldId="265"/>
+            <ac:cxnSpMk id="7" creationId="{B066E489-801F-7BEE-1AC6-77044EC0172F}"/>
+          </ac:cxnSpMkLst>
+        </pc:cxnChg>
+      </pc:sldChg>
     </pc:docChg>
   </pc:docChgLst>
 </pc:chgInfo>
@@ -437,7 +506,7 @@
           <a:p>
             <a:fld id="{40AAFA59-C491-4FF3-95B2-E8877187DFDD}" type="datetimeFigureOut">
               <a:rPr lang="en-US" smtClean="0"/>
-              <a:t>2/18/2026</a:t>
+              <a:t>3/5/2026</a:t>
             </a:fld>
             <a:endParaRPr lang="en-US"/>
           </a:p>
@@ -635,7 +704,7 @@
           <a:p>
             <a:fld id="{40AAFA59-C491-4FF3-95B2-E8877187DFDD}" type="datetimeFigureOut">
               <a:rPr lang="en-US" smtClean="0"/>
-              <a:t>2/18/2026</a:t>
+              <a:t>3/5/2026</a:t>
             </a:fld>
             <a:endParaRPr lang="en-US"/>
           </a:p>
@@ -843,7 +912,7 @@
           <a:p>
             <a:fld id="{40AAFA59-C491-4FF3-95B2-E8877187DFDD}" type="datetimeFigureOut">
               <a:rPr lang="en-US" smtClean="0"/>
-              <a:t>2/18/2026</a:t>
+              <a:t>3/5/2026</a:t>
             </a:fld>
             <a:endParaRPr lang="en-US"/>
           </a:p>
@@ -1041,7 +1110,7 @@
           <a:p>
             <a:fld id="{40AAFA59-C491-4FF3-95B2-E8877187DFDD}" type="datetimeFigureOut">
               <a:rPr lang="en-US" smtClean="0"/>
-              <a:t>2/18/2026</a:t>
+              <a:t>3/5/2026</a:t>
             </a:fld>
             <a:endParaRPr lang="en-US"/>
           </a:p>
@@ -1316,7 +1385,7 @@
           <a:p>
             <a:fld id="{40AAFA59-C491-4FF3-95B2-E8877187DFDD}" type="datetimeFigureOut">
               <a:rPr lang="en-US" smtClean="0"/>
-              <a:t>2/18/2026</a:t>
+              <a:t>3/5/2026</a:t>
             </a:fld>
             <a:endParaRPr lang="en-US"/>
           </a:p>
@@ -1581,7 +1650,7 @@
           <a:p>
             <a:fld id="{40AAFA59-C491-4FF3-95B2-E8877187DFDD}" type="datetimeFigureOut">
               <a:rPr lang="en-US" smtClean="0"/>
-              <a:t>2/18/2026</a:t>
+              <a:t>3/5/2026</a:t>
             </a:fld>
             <a:endParaRPr lang="en-US"/>
           </a:p>
@@ -1993,7 +2062,7 @@
           <a:p>
             <a:fld id="{40AAFA59-C491-4FF3-95B2-E8877187DFDD}" type="datetimeFigureOut">
               <a:rPr lang="en-US" smtClean="0"/>
-              <a:t>2/18/2026</a:t>
+              <a:t>3/5/2026</a:t>
             </a:fld>
             <a:endParaRPr lang="en-US"/>
           </a:p>
@@ -2134,7 +2203,7 @@
           <a:p>
             <a:fld id="{40AAFA59-C491-4FF3-95B2-E8877187DFDD}" type="datetimeFigureOut">
               <a:rPr lang="en-US" smtClean="0"/>
-              <a:t>2/18/2026</a:t>
+              <a:t>3/5/2026</a:t>
             </a:fld>
             <a:endParaRPr lang="en-US"/>
           </a:p>
@@ -2247,7 +2316,7 @@
           <a:p>
             <a:fld id="{40AAFA59-C491-4FF3-95B2-E8877187DFDD}" type="datetimeFigureOut">
               <a:rPr lang="en-US" smtClean="0"/>
-              <a:t>2/18/2026</a:t>
+              <a:t>3/5/2026</a:t>
             </a:fld>
             <a:endParaRPr lang="en-US"/>
           </a:p>
@@ -2558,7 +2627,7 @@
           <a:p>
             <a:fld id="{40AAFA59-C491-4FF3-95B2-E8877187DFDD}" type="datetimeFigureOut">
               <a:rPr lang="en-US" smtClean="0"/>
-              <a:t>2/18/2026</a:t>
+              <a:t>3/5/2026</a:t>
             </a:fld>
             <a:endParaRPr lang="en-US"/>
           </a:p>
@@ -2846,7 +2915,7 @@
           <a:p>
             <a:fld id="{40AAFA59-C491-4FF3-95B2-E8877187DFDD}" type="datetimeFigureOut">
               <a:rPr lang="en-US" smtClean="0"/>
-              <a:t>2/18/2026</a:t>
+              <a:t>3/5/2026</a:t>
             </a:fld>
             <a:endParaRPr lang="en-US"/>
           </a:p>
@@ -3087,7 +3156,7 @@
           <a:p>
             <a:fld id="{40AAFA59-C491-4FF3-95B2-E8877187DFDD}" type="datetimeFigureOut">
               <a:rPr lang="en-US" smtClean="0"/>
-              <a:t>2/18/2026</a:t>
+              <a:t>3/5/2026</a:t>
             </a:fld>
             <a:endParaRPr lang="en-US"/>
           </a:p>
@@ -3573,6 +3642,209 @@
 </p:sld>
 </file>
 
+<file path=ppt/slides/slide10.xml><?xml version="1.0" encoding="utf-8"?>
+<p:sld xmlns:a="http://schemas.openxmlformats.org/drawingml/2006/main" xmlns:r="http://schemas.openxmlformats.org/officeDocument/2006/relationships" xmlns:p="http://schemas.openxmlformats.org/presentationml/2006/main">
+  <p:cSld>
+    <p:spTree>
+      <p:nvGrpSpPr>
+        <p:cNvPr id="1" name=""/>
+        <p:cNvGrpSpPr/>
+        <p:nvPr/>
+      </p:nvGrpSpPr>
+      <p:grpSpPr>
+        <a:xfrm>
+          <a:off x="0" y="0"/>
+          <a:ext cx="0" cy="0"/>
+          <a:chOff x="0" y="0"/>
+          <a:chExt cx="0" cy="0"/>
+        </a:xfrm>
+      </p:grpSpPr>
+      <p:pic>
+        <p:nvPicPr>
+          <p:cNvPr id="5" name="Picture 4">
+            <a:extLst>
+              <a:ext uri="{FF2B5EF4-FFF2-40B4-BE49-F238E27FC236}">
+                <a16:creationId xmlns:a16="http://schemas.microsoft.com/office/drawing/2014/main" id="{776023DB-349E-84E2-C86F-03F8110B33A4}"/>
+              </a:ext>
+            </a:extLst>
+          </p:cNvPr>
+          <p:cNvPicPr>
+            <a:picLocks noChangeAspect="1"/>
+          </p:cNvPicPr>
+          <p:nvPr/>
+        </p:nvPicPr>
+        <p:blipFill>
+          <a:blip r:embed="rId2"/>
+          <a:stretch>
+            <a:fillRect/>
+          </a:stretch>
+        </p:blipFill>
+        <p:spPr>
+          <a:xfrm>
+            <a:off x="3600233" y="2085858"/>
+            <a:ext cx="4991533" cy="2686283"/>
+          </a:xfrm>
+          <a:prstGeom prst="rect">
+            <a:avLst/>
+          </a:prstGeom>
+        </p:spPr>
+      </p:pic>
+      <p:cxnSp>
+        <p:nvCxnSpPr>
+          <p:cNvPr id="7" name="Straight Connector 6">
+            <a:extLst>
+              <a:ext uri="{FF2B5EF4-FFF2-40B4-BE49-F238E27FC236}">
+                <a16:creationId xmlns:a16="http://schemas.microsoft.com/office/drawing/2014/main" id="{B066E489-801F-7BEE-1AC6-77044EC0172F}"/>
+              </a:ext>
+            </a:extLst>
+          </p:cNvPr>
+          <p:cNvCxnSpPr>
+            <a:cxnSpLocks/>
+          </p:cNvCxnSpPr>
+          <p:nvPr/>
+        </p:nvCxnSpPr>
+        <p:spPr>
+          <a:xfrm>
+            <a:off x="5631005" y="2913611"/>
+            <a:ext cx="0" cy="1597368"/>
+          </a:xfrm>
+          <a:prstGeom prst="line">
+            <a:avLst/>
+          </a:prstGeom>
+        </p:spPr>
+        <p:style>
+          <a:lnRef idx="2">
+            <a:schemeClr val="dk1"/>
+          </a:lnRef>
+          <a:fillRef idx="0">
+            <a:schemeClr val="dk1"/>
+          </a:fillRef>
+          <a:effectRef idx="1">
+            <a:schemeClr val="dk1"/>
+          </a:effectRef>
+          <a:fontRef idx="minor">
+            <a:schemeClr val="tx1"/>
+          </a:fontRef>
+        </p:style>
+      </p:cxnSp>
+      <p:sp>
+        <p:nvSpPr>
+          <p:cNvPr id="9" name="TextBox 8">
+            <a:extLst>
+              <a:ext uri="{FF2B5EF4-FFF2-40B4-BE49-F238E27FC236}">
+                <a16:creationId xmlns:a16="http://schemas.microsoft.com/office/drawing/2014/main" id="{C500F999-4E38-9E43-24B6-29A32C72BDB8}"/>
+              </a:ext>
+            </a:extLst>
+          </p:cNvPr>
+          <p:cNvSpPr txBox="1"/>
+          <p:nvPr/>
+        </p:nvSpPr>
+        <p:spPr>
+          <a:xfrm>
+            <a:off x="569423" y="353290"/>
+            <a:ext cx="4239491" cy="1477328"/>
+          </a:xfrm>
+          <a:prstGeom prst="rect">
+            <a:avLst/>
+          </a:prstGeom>
+          <a:noFill/>
+        </p:spPr>
+        <p:txBody>
+          <a:bodyPr wrap="square" rtlCol="0">
+            <a:spAutoFit/>
+          </a:bodyPr>
+          <a:lstStyle/>
+          <a:p>
+            <a:r>
+              <a:rPr lang="en-US" dirty="0"/>
+              <a:t>1.  Conver x-scale to 0-10 sec for each application, trial, participant.  Take 10 sec and divide by total number of data in trial, and that will give a time for each data point.  </a:t>
+            </a:r>
+          </a:p>
+        </p:txBody>
+      </p:sp>
+      <p:sp>
+        <p:nvSpPr>
+          <p:cNvPr id="10" name="TextBox 9">
+            <a:extLst>
+              <a:ext uri="{FF2B5EF4-FFF2-40B4-BE49-F238E27FC236}">
+                <a16:creationId xmlns:a16="http://schemas.microsoft.com/office/drawing/2014/main" id="{26A3D7C1-686F-6F31-A87D-D6BDCAD0B298}"/>
+              </a:ext>
+            </a:extLst>
+          </p:cNvPr>
+          <p:cNvSpPr txBox="1"/>
+          <p:nvPr/>
+        </p:nvSpPr>
+        <p:spPr>
+          <a:xfrm>
+            <a:off x="5069380" y="347368"/>
+            <a:ext cx="4239491" cy="1200329"/>
+          </a:xfrm>
+          <a:prstGeom prst="rect">
+            <a:avLst/>
+          </a:prstGeom>
+          <a:noFill/>
+        </p:spPr>
+        <p:txBody>
+          <a:bodyPr wrap="square" rtlCol="0">
+            <a:spAutoFit/>
+          </a:bodyPr>
+          <a:lstStyle/>
+          <a:p>
+            <a:r>
+              <a:rPr lang="en-US" dirty="0"/>
+              <a:t>2.  Try re-plotting all applications / trials with vertical line separating non-moving from moving section.  Should look something like below. </a:t>
+            </a:r>
+          </a:p>
+        </p:txBody>
+      </p:sp>
+      <p:sp>
+        <p:nvSpPr>
+          <p:cNvPr id="11" name="TextBox 10">
+            <a:extLst>
+              <a:ext uri="{FF2B5EF4-FFF2-40B4-BE49-F238E27FC236}">
+                <a16:creationId xmlns:a16="http://schemas.microsoft.com/office/drawing/2014/main" id="{03EB4E9E-0E9F-C4ED-5409-7AA4AF1A72BB}"/>
+              </a:ext>
+            </a:extLst>
+          </p:cNvPr>
+          <p:cNvSpPr txBox="1"/>
+          <p:nvPr/>
+        </p:nvSpPr>
+        <p:spPr>
+          <a:xfrm>
+            <a:off x="569422" y="5027381"/>
+            <a:ext cx="6833062" cy="1477328"/>
+          </a:xfrm>
+          <a:prstGeom prst="rect">
+            <a:avLst/>
+          </a:prstGeom>
+          <a:noFill/>
+        </p:spPr>
+        <p:txBody>
+          <a:bodyPr wrap="square" rtlCol="0">
+            <a:spAutoFit/>
+          </a:bodyPr>
+          <a:lstStyle/>
+          <a:p>
+            <a:r>
+              <a:rPr lang="en-US" dirty="0"/>
+              <a:t>3.  Split each set of data to non-moving and moving data and take std of each.  Put those std values into new data frame where column 0 might be participant, column 1is application 0 or 1, column 2 is trial # (0,1,or 2). Column 3 is std of non-moving.  Column 4 is std of moving.  </a:t>
+            </a:r>
+          </a:p>
+        </p:txBody>
+      </p:sp>
+    </p:spTree>
+    <p:extLst>
+      <p:ext uri="{BB962C8B-B14F-4D97-AF65-F5344CB8AC3E}">
+        <p14:creationId xmlns:p14="http://schemas.microsoft.com/office/powerpoint/2010/main" val="2413865537"/>
+      </p:ext>
+    </p:extLst>
+  </p:cSld>
+  <p:clrMapOvr>
+    <a:masterClrMapping/>
+  </p:clrMapOvr>
+</p:sld>
+</file>
+
 <file path=ppt/slides/slide2.xml><?xml version="1.0" encoding="utf-8"?>
 <p:sld xmlns:a="http://schemas.openxmlformats.org/drawingml/2006/main" xmlns:r="http://schemas.openxmlformats.org/officeDocument/2006/relationships" xmlns:p="http://schemas.openxmlformats.org/presentationml/2006/main">
   <p:cSld>
@@ -4747,6 +5019,98 @@
     <p:extLst>
       <p:ext uri="{BB962C8B-B14F-4D97-AF65-F5344CB8AC3E}">
         <p14:creationId xmlns:p14="http://schemas.microsoft.com/office/powerpoint/2010/main" val="1851546690"/>
+      </p:ext>
+    </p:extLst>
+  </p:cSld>
+  <p:clrMapOvr>
+    <a:masterClrMapping/>
+  </p:clrMapOvr>
+</p:sld>
+</file>
+
+<file path=ppt/slides/slide9.xml><?xml version="1.0" encoding="utf-8"?>
+<p:sld xmlns:a="http://schemas.openxmlformats.org/drawingml/2006/main" xmlns:r="http://schemas.openxmlformats.org/officeDocument/2006/relationships" xmlns:p="http://schemas.openxmlformats.org/presentationml/2006/main">
+  <p:cSld>
+    <p:spTree>
+      <p:nvGrpSpPr>
+        <p:cNvPr id="1" name="">
+          <a:extLst>
+            <a:ext uri="{FF2B5EF4-FFF2-40B4-BE49-F238E27FC236}">
+              <a16:creationId xmlns:a16="http://schemas.microsoft.com/office/drawing/2014/main" id="{94A2C197-BB23-5701-3CCE-36D9AEB76570}"/>
+            </a:ext>
+          </a:extLst>
+        </p:cNvPr>
+        <p:cNvGrpSpPr/>
+        <p:nvPr/>
+      </p:nvGrpSpPr>
+      <p:grpSpPr>
+        <a:xfrm>
+          <a:off x="0" y="0"/>
+          <a:ext cx="0" cy="0"/>
+          <a:chOff x="0" y="0"/>
+          <a:chExt cx="0" cy="0"/>
+        </a:xfrm>
+      </p:grpSpPr>
+      <p:sp>
+        <p:nvSpPr>
+          <p:cNvPr id="2" name="Title 1">
+            <a:extLst>
+              <a:ext uri="{FF2B5EF4-FFF2-40B4-BE49-F238E27FC236}">
+                <a16:creationId xmlns:a16="http://schemas.microsoft.com/office/drawing/2014/main" id="{9CA0FF23-C90E-1BE4-BDE4-F98A3CDE6FBA}"/>
+              </a:ext>
+            </a:extLst>
+          </p:cNvPr>
+          <p:cNvSpPr>
+            <a:spLocks noGrp="1"/>
+          </p:cNvSpPr>
+          <p:nvPr>
+            <p:ph type="ctrTitle"/>
+          </p:nvPr>
+        </p:nvSpPr>
+        <p:spPr/>
+        <p:txBody>
+          <a:bodyPr/>
+          <a:lstStyle/>
+          <a:p>
+            <a:r>
+              <a:rPr lang="en-US" dirty="0"/>
+              <a:t>Zeyad Abduction Analysis</a:t>
+            </a:r>
+          </a:p>
+        </p:txBody>
+      </p:sp>
+      <p:sp>
+        <p:nvSpPr>
+          <p:cNvPr id="3" name="Subtitle 2">
+            <a:extLst>
+              <a:ext uri="{FF2B5EF4-FFF2-40B4-BE49-F238E27FC236}">
+                <a16:creationId xmlns:a16="http://schemas.microsoft.com/office/drawing/2014/main" id="{27390C7A-468F-1B77-5F21-0E433834E152}"/>
+              </a:ext>
+            </a:extLst>
+          </p:cNvPr>
+          <p:cNvSpPr>
+            <a:spLocks noGrp="1"/>
+          </p:cNvSpPr>
+          <p:nvPr>
+            <p:ph type="subTitle" idx="1"/>
+          </p:nvPr>
+        </p:nvSpPr>
+        <p:spPr/>
+        <p:txBody>
+          <a:bodyPr/>
+          <a:lstStyle/>
+          <a:p>
+            <a:r>
+              <a:rPr lang="en-US" dirty="0"/>
+              <a:t>3_5_26</a:t>
+            </a:r>
+          </a:p>
+        </p:txBody>
+      </p:sp>
+    </p:spTree>
+    <p:extLst>
+      <p:ext uri="{BB962C8B-B14F-4D97-AF65-F5344CB8AC3E}">
+        <p14:creationId xmlns:p14="http://schemas.microsoft.com/office/powerpoint/2010/main" val="640338337"/>
       </p:ext>
     </p:extLst>
   </p:cSld>

</xml_diff>